<commit_message>
Use plain scientific wording throughout the presentation
Co-Authored-By: Claude Opus 5.5 <noreply@anthropic.com>
</commit_message>
<xml_diff>
--- a/docs/paper/presentation.pptx
+++ b/docs/paper/presentation.pptx
@@ -515,7 +515,7 @@
           <a:p>
             <a:r>
               <a:rPr lang="en-US" dirty="0"/>
-              <a:t>This project asks why a robot that plans with an AI world model is slow, finds the answer in data, and fixes it. The title is the outcome: planning fast enough for a control loop, with the same model and the same success.</a:t>
+              <a:t>This study profiles the inference latency of a world-model planner, identifies its bottlenecks from measured data, and evaluates a fused GPU implementation that removes them without retraining the model.</a:t>
             </a:r>
             <a:endParaRPr lang="en-US" dirty="0"/>
           </a:p>
@@ -603,7 +603,7 @@
           <a:p>
             <a:r>
               <a:rPr lang="en-US" dirty="0"/>
-              <a:t>The headline. Thirteen times faster than the reference, and almost four times faster than a PyTorch implementation that already uses every standard trick. Just as important for a controller, it is predictable: the spread is under a millisecond.</a:t>
+              <a:t>Latency is reduced 13.4-fold relative to the reference and 3.9-fold relative to an optimised PyTorch implementation using compilation, CUDA Graphs and BF16. Latency variability is also reduced: the interquartile range is 0.7 ms.</a:t>
             </a:r>
             <a:endParaRPr lang="en-US" dirty="0"/>
           </a:p>
@@ -691,7 +691,7 @@
           <a:p>
             <a:r>
               <a:rPr lang="en-US" dirty="0"/>
-              <a:t>The guard rail. The robot succeeds as often as before, within what 300 paired episodes can resolve, about six points. The kernel's arithmetic error matches the half-precision arithmetic that was already accepted.</a:t>
+              <a:t>No detectable change in task success at the resolution of 300 paired episodes (approximately 6 percentage points at 80% power). Numerical error relative to FP32 is within the range of the accepted BF16 implementation.</a:t>
             </a:r>
             <a:endParaRPr lang="en-US" dirty="0"/>
           </a:p>
@@ -779,7 +779,7 @@
           <a:p>
             <a:r>
               <a:rPr lang="en-US" dirty="0"/>
-              <a:t>The objectives were met, and the limits are stated with them. The speed-up is large and stable; the claim about success is bounded by the sample size; the numbers are specific to this model and GPU even though the mechanism is general.</a:t>
+              <a:t>All four objectives were met. The latency reduction is large and reproducible; the task-success result is bounded by sample size; the measured values are specific to this model and GPU, while the identified mechanism is general.</a:t>
             </a:r>
             <a:endParaRPr lang="en-US" dirty="0"/>
           </a:p>
@@ -867,7 +867,7 @@
           <a:p>
             <a:r>
               <a:rPr lang="en-US" dirty="0"/>
-              <a:t>Four directions. The first is the immediate payoff: a fast planner can afford a bigger search. The others push latency further, test generality, and take the result to a real robot.</a:t>
+              <a:t>Four directions: the latency-success trade-off of the search budget, further latency reduction, generalisation to other models and hardware, and higher-resolution and physical evaluation.</a:t>
             </a:r>
             <a:endParaRPr lang="en-US" dirty="0"/>
           </a:p>
@@ -955,7 +955,7 @@
           <a:p>
             <a:r>
               <a:rPr lang="en-US" dirty="0"/>
-              <a:t>Three sentences to end on, then questions.</a:t>
+              <a:t>Summary of findings.</a:t>
             </a:r>
             <a:endParaRPr lang="en-US" dirty="0"/>
           </a:p>
@@ -1043,7 +1043,7 @@
           <a:p>
             <a:r>
               <a:rPr lang="en-US" dirty="0"/>
-              <a:t>Four numbers to keep in mind: 622 milliseconds before, 46.5 after, thirteen times faster, and no change in how often the robot succeeds. The rest of the talk explains how the data led from the first number to the second.</a:t>
+              <a:t>Summary of the study: reference latency 622 ms, final latency 46.5 ms, a 13.4-fold reduction, and no detectable change in task success. The following slides present the profile, the design derived from it, and the evaluation.</a:t>
             </a:r>
             <a:endParaRPr lang="en-US" dirty="0"/>
           </a:p>
@@ -1131,7 +1131,7 @@
           <a:p>
             <a:r>
               <a:rPr lang="en-US" dirty="0"/>
-              <a:t>The motivation is control. Larger world models take tens of seconds per plan. LeWM brought that under a second by being small. But a robot needs tens of milliseconds, and a model this small should be able to deliver that.</a:t>
+              <a:t>Closed-loop control requires planning latency below the control period. Larger world models require tens of seconds per plan; LeWM requires 622 ms on an H100, although its arithmetic content corresponds to milliseconds.</a:t>
             </a:r>
             <a:endParaRPr lang="en-US" dirty="0"/>
           </a:p>
@@ -1219,7 +1219,7 @@
           <a:p>
             <a:r>
               <a:rPr lang="en-US" dirty="0"/>
-              <a:t>Four objectives, one per stage of the work. The project is an analytics project about an AI system: the data are timings and outcomes, the pattern discovery is a fitted model of where time goes, and the evaluation is statistical.</a:t>
+              <a:t>Four objectives, one per stage of the study. The object of study is an AI system; the method is an analytics pipeline over its measured behaviour: data collection and preparation, pattern discovery with a fitted latency model, and statistical evaluation.</a:t>
             </a:r>
             <a:endParaRPr lang="en-US" dirty="0"/>
           </a:p>
@@ -1307,7 +1307,7 @@
           <a:p>
             <a:r>
               <a:rPr lang="en-US" dirty="0"/>
-              <a:t>Three lines of work meet here. World models, where speed has been treated as a property of the model. Sampling-based search, where iCEM cut samples but related work warns that samples are not time. And GPU inference, where the megakernel is the newest tool but has only been used for language models.</a:t>
+              <a:t>Three bodies of work are relevant: JEPA world models, in which planning latency has been reduced only by changing the model; sampling-based search, in which iCEM reduces sample counts but sample count does not determine latency; and GPU inference, in which megakernels have so far been applied only to language models.</a:t>
             </a:r>
             <a:endParaRPr lang="en-US" dirty="0"/>
           </a:p>
@@ -1395,7 +1395,7 @@
           <a:p>
             <a:r>
               <a:rPr lang="en-US" dirty="0"/>
-              <a:t>The pipeline. Collect timings and outcomes, prepare them into tidy tables, discover where the time goes, design against it, evaluate, deploy. Probes are configurations that differ in one respect, used only to isolate an effect. Every design change went back through profiling before it was kept.</a:t>
+              <a:t>Methodology. Timings and outcomes are collected, prepared into tidy tables and analysed to locate the latency; the design follows from the analysis and is evaluated with the same instruments. Probes are configurations that differ from a system in one respect and isolate a single effect. Each design change was re-profiled before adoption.</a:t>
             </a:r>
             <a:endParaRPr lang="en-US" dirty="0"/>
           </a:p>
@@ -1483,7 +1483,7 @@
           <a:p>
             <a:r>
               <a:rPr lang="en-US" dirty="0"/>
-              <a:t>The profile. A third of the time recomputes something that never changes during a plan. Most of the rest is the search, but at about four hundred microseconds per layer evaluation for a few microseconds of arithmetic, it is not computing most of the time.</a:t>
+              <a:t>Compute profile. One third of the latency recomputes image embeddings that are constant within a plan. Most of the remainder is the search, at approximately 409 microseconds per layer evaluation against approximately 3 microseconds of arithmetic.</a:t>
             </a:r>
             <a:endParaRPr lang="en-US" dirty="0"/>
           </a:p>
@@ -1571,7 +1571,7 @@
           <a:p>
             <a:r>
               <a:rPr lang="en-US" dirty="0"/>
-              <a:t>The key pattern. A straight-line model fitted to latency against workload shows the eager planner's cost is almost entirely fixed: a few hundred kernel launches from Python per call. That also explains why the sample-efficient search algorithm looked useless: it reduces work that was not the cost.</a:t>
+              <a:t>Scaling analysis. A linear model of latency against workload shows that the eager planner's cost is almost entirely fixed, consistent with several hundred kernel launches from Python per call. This also explains the absence of a gain from iCEM under eager execution: it reduces work that is not the dominant cost.</a:t>
             </a:r>
             <a:endParaRPr lang="en-US" dirty="0"/>
           </a:p>
@@ -1659,7 +1659,7 @@
           <a:p>
             <a:r>
               <a:rPr lang="en-US" dirty="0"/>
-              <a:t>Each element answers one finding. Encoding once removes the third. iCEM cuts work once overhead is gone. The persistent kernel removes launches and CPU round trips. Spreading the model across a cluster and streaming weights keeps every step of the long chain as short as the hardware allows.</a:t>
+              <a:t>Each design element addresses one finding: single encoding removes the redundant third; iCEM reduces work once fixed overhead is removed; the persistent kernel removes launches and CPU round trips; cluster-level parallelism and weight streaming minimise the latency of each step of the dependent chain.</a:t>
             </a:r>
             <a:endParaRPr lang="en-US" dirty="0"/>
           </a:p>
@@ -2250,7 +2250,7 @@
                 <a:ea typeface="Cambria" pitchFamily="34" charset="-122"/>
                 <a:cs typeface="Cambria" pitchFamily="34" charset="-120"/>
               </a:rPr>
-              <a:t>Evaluation: 622 ms to 46.5 ms on the same GPU</a:t>
+              <a:t>Results: planning latency</a:t>
             </a:r>
             <a:endParaRPr lang="en-US" sz="2800" dirty="0"/>
           </a:p>
@@ -2745,7 +2745,7 @@
                 <a:ea typeface="Cambria" pitchFamily="34" charset="-122"/>
                 <a:cs typeface="Cambria" pitchFamily="34" charset="-120"/>
               </a:rPr>
-              <a:t>Evaluation: the robot succeeds just as often</a:t>
+              <a:t>Results: task success and numerical fidelity</a:t>
             </a:r>
             <a:endParaRPr lang="en-US" sz="2800" dirty="0"/>
           </a:p>
@@ -2854,7 +2854,7 @@
                 <a:ea typeface="Calibri" pitchFamily="34" charset="-122"/>
                 <a:cs typeface="Calibri" pitchFamily="34" charset="-120"/>
               </a:rPr>
-              <a:t>Disagreements are search randomness: the optimised PyTorch planner disagrees on 36.</a:t>
+              <a:t>Discordant episodes reflect stochastic search; the optimised PyTorch planner is discordant on 36.</a:t>
             </a:r>
             <a:endParaRPr lang="en-US" sz="1100" dirty="0"/>
           </a:p>
@@ -3017,7 +3017,7 @@
                 <a:ea typeface="Cambria" pitchFamily="34" charset="-122"/>
                 <a:cs typeface="Cambria" pitchFamily="34" charset="-120"/>
               </a:rPr>
-              <a:t>Conclusions, and what I cannot claim</a:t>
+              <a:t>Conclusions and limitations</a:t>
             </a:r>
             <a:endParaRPr lang="en-US" sz="2800" dirty="0"/>
           </a:p>
@@ -3395,7 +3395,7 @@
                 <a:ea typeface="Cambria" pitchFamily="34" charset="-122"/>
                 <a:cs typeface="Cambria" pitchFamily="34" charset="-120"/>
               </a:rPr>
-              <a:t>Limits</a:t>
+              <a:t>Limitations</a:t>
             </a:r>
             <a:endParaRPr lang="en-US" sz="1500" dirty="0"/>
           </a:p>
@@ -3438,7 +3438,7 @@
                 <a:ea typeface="Calibri" pitchFamily="34" charset="-122"/>
                 <a:cs typeface="Calibri" pitchFamily="34" charset="-120"/>
               </a:rPr>
-              <a:t>300 pairs resolve about 6 points of success, no less.</a:t>
+              <a:t>300 paired episodes resolve differences of about 6 percentage points.</a:t>
             </a:r>
             <a:endParaRPr lang="en-US" sz="1100" dirty="0"/>
           </a:p>
@@ -3459,7 +3459,7 @@
                 <a:ea typeface="Calibri" pitchFamily="34" charset="-122"/>
                 <a:cs typeface="Calibri" pitchFamily="34" charset="-120"/>
               </a:rPr>
-              <a:t>Some profile stages attributed by difference.</a:t>
+              <a:t>Some profile stages are attributed by difference.</a:t>
             </a:r>
             <a:endParaRPr lang="en-US" sz="1100" dirty="0"/>
           </a:p>
@@ -3501,7 +3501,7 @@
                 <a:ea typeface="Calibri" pitchFamily="34" charset="-122"/>
                 <a:cs typeface="Calibri" pitchFamily="34" charset="-120"/>
               </a:rPr>
-              <a:t>Simulation; only the planning call optimised.</a:t>
+              <a:t>Simulation only; only the planning call was optimised.</a:t>
             </a:r>
             <a:endParaRPr lang="en-US" sz="1100" dirty="0"/>
           </a:p>
@@ -3522,7 +3522,7 @@
                 <a:ea typeface="Calibri" pitchFamily="34" charset="-122"/>
                 <a:cs typeface="Calibri" pitchFamily="34" charset="-120"/>
               </a:rPr>
-              <a:t>PyTorch timings vary up to 18% between passes; the kernel's about 2%.</a:t>
+              <a:t>PyTorch latency varied by up to 18% between passes; kernel latency by about 2%.</a:t>
             </a:r>
             <a:endParaRPr lang="en-US" sz="1100" dirty="0"/>
           </a:p>
@@ -3731,7 +3731,7 @@
                 <a:ea typeface="Calibri" pitchFamily="34" charset="-122"/>
                 <a:cs typeface="Calibri" pitchFamily="34" charset="-120"/>
               </a:rPr>
-              <a:t>Spend the saved time on better plans</a:t>
+              <a:t>Search budget versus task success</a:t>
             </a:r>
             <a:endParaRPr lang="en-US" sz="1250" dirty="0"/>
           </a:p>
@@ -3751,7 +3751,7 @@
                 <a:ea typeface="Calibri" pitchFamily="34" charset="-122"/>
                 <a:cs typeface="Calibri" pitchFamily="34" charset="-120"/>
               </a:rPr>
-              <a:t>More iterations or candidates still fit a 100 ms period: map the latency-success trade-off.</a:t>
+              <a:t>Larger iteration and candidate budgets remain within a 100 ms control period; characterise the latency-success trade-off.</a:t>
             </a:r>
             <a:endParaRPr lang="en-US" sz="1250" dirty="0"/>
           </a:p>
@@ -3857,7 +3857,7 @@
                 <a:ea typeface="Calibri" pitchFamily="34" charset="-122"/>
                 <a:cs typeface="Calibri" pitchFamily="34" charset="-120"/>
               </a:rPr>
-              <a:t>Shorten the remaining chain</a:t>
+              <a:t>Reducing the dependent computation chain</a:t>
             </a:r>
             <a:endParaRPr lang="en-US" sz="1250" dirty="0"/>
           </a:p>
@@ -3877,7 +3877,7 @@
                 <a:ea typeface="Calibri" pitchFamily="34" charset="-122"/>
                 <a:cs typeface="Calibri" pitchFamily="34" charset="-120"/>
               </a:rPr>
-              <a:t>Combine with a one-pass rollout model, or one layer per cluster with candidates streaming through.</a:t>
+              <a:t>Combination with single-pass rollout models; layer-per-cluster pipelining.</a:t>
             </a:r>
             <a:endParaRPr lang="en-US" sz="1250" dirty="0"/>
           </a:p>
@@ -3983,7 +3983,7 @@
                 <a:ea typeface="Calibri" pitchFamily="34" charset="-122"/>
                 <a:cs typeface="Calibri" pitchFamily="34" charset="-120"/>
               </a:rPr>
-              <a:t>Other models and hardware</a:t>
+              <a:t>Generalisation to other models and hardware</a:t>
             </a:r>
             <a:endParaRPr lang="en-US" sz="1250" dirty="0"/>
           </a:p>
@@ -4003,7 +4003,7 @@
                 <a:ea typeface="Calibri" pitchFamily="34" charset="-122"/>
                 <a:cs typeface="Calibri" pitchFamily="34" charset="-120"/>
               </a:rPr>
-              <a:t>Larger world models, onboard robot computers; automatic megakernel compilers.</a:t>
+              <a:t>Larger world models, embedded robot computers, automatic megakernel compilation.</a:t>
             </a:r>
             <a:endParaRPr lang="en-US" sz="1250" dirty="0"/>
           </a:p>
@@ -4109,7 +4109,7 @@
                 <a:ea typeface="Calibri" pitchFamily="34" charset="-122"/>
                 <a:cs typeface="Calibri" pitchFamily="34" charset="-120"/>
               </a:rPr>
-              <a:t>Evaluate at deployment resolution</a:t>
+              <a:t>Higher-resolution and physical evaluation</a:t>
             </a:r>
             <a:endParaRPr lang="en-US" sz="1250" dirty="0"/>
           </a:p>
@@ -4129,7 +4129,7 @@
                 <a:ea typeface="Calibri" pitchFamily="34" charset="-122"/>
                 <a:cs typeface="Calibri" pitchFamily="34" charset="-120"/>
               </a:rPr>
-              <a:t>About 2,500 paired episodes for 2 points, now minutes of planning; then a physical robot.</a:t>
+              <a:t>Approximately 2,500 paired episodes to resolve 2 percentage points; evaluation on a physical robot.</a:t>
             </a:r>
             <a:endParaRPr lang="en-US" sz="1250" dirty="0"/>
           </a:p>
@@ -4239,7 +4239,7 @@
                 <a:ea typeface="Cambria" pitchFamily="34" charset="-122"/>
                 <a:cs typeface="Cambria" pitchFamily="34" charset="-120"/>
               </a:rPr>
-              <a:t>Take-home</a:t>
+              <a:t>Summary</a:t>
             </a:r>
             <a:endParaRPr lang="en-US" sz="2800" dirty="0"/>
           </a:p>
@@ -4282,7 +4282,7 @@
                 <a:ea typeface="Calibri" pitchFamily="34" charset="-122"/>
                 <a:cs typeface="Calibri" pitchFamily="34" charset="-120"/>
               </a:rPr>
-              <a:t>Profile before optimising: the world-model planner's time was overhead, not arithmetic.</a:t>
+              <a:t>The reference planner's latency was dominated by execution overhead, not arithmetic.</a:t>
             </a:r>
             <a:endParaRPr lang="en-US" sz="1700" dirty="0"/>
           </a:p>
@@ -4303,7 +4303,7 @@
                 <a:ea typeface="Calibri" pitchFamily="34" charset="-122"/>
                 <a:cs typeface="Calibri" pitchFamily="34" charset="-120"/>
               </a:rPr>
-              <a:t>A one-line fitted model of latency against workload told which fix would pay, and why the smarter search had looked useless.</a:t>
+              <a:t>A linear latency-scaling model identified the bottleneck regime and predicted when iCEM reduces latency.</a:t>
             </a:r>
             <a:endParaRPr lang="en-US" sz="1700" dirty="0"/>
           </a:p>
@@ -4321,7 +4321,7 @@
                 <a:ea typeface="Calibri" pitchFamily="34" charset="-122"/>
                 <a:cs typeface="Calibri" pitchFamily="34" charset="-120"/>
               </a:rPr>
-              <a:t>One GPU program per plan: 622 ms to 46.5 ms on the same H100, same model, same task success.</a:t>
+              <a:t>A single persistent GPU kernel per plan reduces latency from 622 ms to 46.5 ms on the same H100, with the same model and no detectable change in task success.</a:t>
             </a:r>
             <a:endParaRPr lang="en-US" sz="1700" dirty="0"/>
           </a:p>
@@ -4424,7 +4424,7 @@
                 <a:ea typeface="Cambria" pitchFamily="34" charset="-122"/>
                 <a:cs typeface="Cambria" pitchFamily="34" charset="-120"/>
               </a:rPr>
-              <a:t>The project in one slide</a:t>
+              <a:t>Overview</a:t>
             </a:r>
             <a:endParaRPr lang="en-US" sz="2800" dirty="0"/>
           </a:p>
@@ -4467,7 +4467,7 @@
                 <a:ea typeface="Calibri" pitchFamily="34" charset="-122"/>
                 <a:cs typeface="Calibri" pitchFamily="34" charset="-120"/>
               </a:rPr>
-              <a:t>LeWM is a small AI world model that lets a robot plan by imagining thousands of possible futures. One plan still takes 622 ms on an H100 GPU.</a:t>
+              <a:t>LeWM is a 15M-parameter world model that plans by evaluating thousands of predicted action outcomes. One plan takes 622 ms on an H100 GPU.</a:t>
             </a:r>
             <a:endParaRPr lang="en-US" sz="1400" dirty="0"/>
           </a:p>
@@ -4488,7 +4488,7 @@
                 <a:ea typeface="Calibri" pitchFamily="34" charset="-122"/>
                 <a:cs typeface="Calibri" pitchFamily="34" charset="-120"/>
               </a:rPr>
-              <a:t>Question: where does that time go, and how much can be removed without retraining the model or making the robot less successful?</a:t>
+              <a:t>Research question: where is the planning latency spent, and how much can be removed without retraining the model or reducing task success?</a:t>
             </a:r>
             <a:endParaRPr lang="en-US" sz="1400" dirty="0"/>
           </a:p>
@@ -4509,7 +4509,7 @@
                 <a:ea typeface="Calibri" pitchFamily="34" charset="-122"/>
                 <a:cs typeface="Calibri" pitchFamily="34" charset="-120"/>
               </a:rPr>
-              <a:t>Method: an analytics pipeline over 11,942 timed calls and 900 episode outcomes: profile, model the bottleneck, design, evaluate with paired statistics.</a:t>
+              <a:t>Method: compute profiling of 11,942 timed calls, a fitted latency-scaling model, solution design, and paired statistical evaluation on 900 episode outcomes.</a:t>
             </a:r>
             <a:endParaRPr lang="en-US" sz="1400" dirty="0"/>
           </a:p>
@@ -4530,7 +4530,7 @@
                 <a:ea typeface="Calibri" pitchFamily="34" charset="-122"/>
                 <a:cs typeface="Calibri" pitchFamily="34" charset="-120"/>
               </a:rPr>
-              <a:t>Answer: the time was overhead, not computation. One fused GPU program per plan takes 46.5 ms, with task success unchanged.</a:t>
+              <a:t>Result: latency was dominated by execution overhead rather than computation. A single persistent GPU kernel per plan reduces latency to 46.5 ms with no detectable change in task success.</a:t>
             </a:r>
             <a:endParaRPr lang="en-US" sz="1400" dirty="0"/>
           </a:p>
@@ -5160,7 +5160,7 @@
                 <a:ea typeface="Cambria" pitchFamily="34" charset="-122"/>
                 <a:cs typeface="Cambria" pitchFamily="34" charset="-120"/>
               </a:rPr>
-              <a:t>Why it matters: robots plan against a clock</a:t>
+              <a:t>Motivation</a:t>
             </a:r>
             <a:endParaRPr lang="en-US" sz="2800" dirty="0"/>
           </a:p>
@@ -5203,7 +5203,7 @@
                 <a:ea typeface="Calibri" pitchFamily="34" charset="-122"/>
                 <a:cs typeface="Calibri" pitchFamily="34" charset="-120"/>
               </a:rPr>
-              <a:t>A world model predicts what happens next; a robot plans by imagining many action sequences and executing the best.</a:t>
+              <a:t>A world model predicts future states; a planner evaluates many candidate action sequences with it and executes the best.</a:t>
             </a:r>
             <a:endParaRPr lang="en-US" sz="1400" dirty="0"/>
           </a:p>
@@ -5266,7 +5266,7 @@
                 <a:ea typeface="Calibri" pitchFamily="34" charset="-122"/>
                 <a:cs typeface="Calibri" pitchFamily="34" charset="-120"/>
               </a:rPr>
-              <a:t>The model is tiny: its arithmetic per plan should take milliseconds. Something else is using the time.</a:t>
+              <a:t>The arithmetic content of a plan corresponds to milliseconds of GPU time; the remaining latency is not attributable to computation.</a:t>
             </a:r>
             <a:endParaRPr lang="en-US" sz="1400" dirty="0"/>
           </a:p>
@@ -5493,7 +5493,7 @@
                 <a:ea typeface="Calibri" pitchFamily="34" charset="-122"/>
                 <a:cs typeface="Calibri" pitchFamily="34" charset="-120"/>
               </a:rPr>
-              <a:t>imagined futures</a:t>
+              <a:t>rollouts per</a:t>
             </a:r>
             <a:endParaRPr lang="en-US" sz="1000" dirty="0"/>
           </a:p>
@@ -5510,7 +5510,7 @@
                 <a:ea typeface="Calibri" pitchFamily="34" charset="-122"/>
                 <a:cs typeface="Calibri" pitchFamily="34" charset="-120"/>
               </a:rPr>
-              <a:t>per reference plan</a:t>
+              <a:t>reference plan</a:t>
             </a:r>
             <a:endParaRPr lang="en-US" sz="1000" dirty="0"/>
           </a:p>
@@ -6433,7 +6433,7 @@
                 <a:ea typeface="Cambria" pitchFamily="34" charset="-122"/>
                 <a:cs typeface="Cambria" pitchFamily="34" charset="-120"/>
               </a:rPr>
-              <a:t>Background: three lines of work, one gap</a:t>
+              <a:t>Background and research gap</a:t>
             </a:r>
             <a:endParaRPr lang="en-US" sz="2800" dirty="0"/>
           </a:p>
@@ -6787,7 +6787,7 @@
                 <a:ea typeface="Calibri" pitchFamily="34" charset="-122"/>
                 <a:cs typeface="Calibri" pitchFamily="34" charset="-120"/>
               </a:rPr>
-              <a:t>The gap. </a:t>
+              <a:t>Research gap. </a:t>
             </a:r>
             <a:pPr indent="0" marL="0">
               <a:buNone/>
@@ -6801,7 +6801,7 @@
                 <a:ea typeface="Calibri" pitchFamily="34" charset="-122"/>
                 <a:cs typeface="Calibri" pitchFamily="34" charset="-120"/>
               </a:rPr>
-              <a:t>No one has profiled where a world-model planner's time goes, measured whether sample-efficient search saves time in practice, or fused a whole planning loop, with a neural encoder, rollouts, scoring and elite selection, into one GPU program.</a:t>
+              <a:t>No prior work has profiled where a world-model planner's latency is spent, measured whether sample-efficient search saves time in practice, or fused a whole planning loop, with a neural encoder, rollouts, scoring and elite selection, into one GPU program.</a:t>
             </a:r>
             <a:endParaRPr lang="en-US" sz="1200" dirty="0"/>
           </a:p>
@@ -6904,7 +6904,7 @@
                 <a:ea typeface="Cambria" pitchFamily="34" charset="-122"/>
                 <a:cs typeface="Cambria" pitchFamily="34" charset="-120"/>
               </a:rPr>
-              <a:t>Method: an analytics pipeline over the planner</a:t>
+              <a:t>Methodology</a:t>
             </a:r>
             <a:endParaRPr lang="en-US" sz="2800" dirty="0"/>
           </a:p>
@@ -7346,7 +7346,7 @@
                 <a:ea typeface="Cambria" pitchFamily="34" charset="-122"/>
                 <a:cs typeface="Cambria" pitchFamily="34" charset="-120"/>
               </a:rPr>
-              <a:t>Finding: where a plan's 622 ms goes</a:t>
+              <a:t>Compute profile of the reference planner</a:t>
             </a:r>
             <a:endParaRPr lang="en-US" sz="2800" dirty="0"/>
           </a:p>
@@ -7455,7 +7455,7 @@
                 <a:ea typeface="Calibri" pitchFamily="34" charset="-122"/>
                 <a:cs typeface="Calibri" pitchFamily="34" charset="-120"/>
               </a:rPr>
-              <a:t>7%: waiting on the CPU between iterations.</a:t>
+              <a:t>7%: CPU synchronisation between iterations.</a:t>
             </a:r>
             <a:endParaRPr lang="en-US" sz="1150" dirty="0"/>
           </a:p>
@@ -7618,7 +7618,7 @@
                 <a:ea typeface="Cambria" pitchFamily="34" charset="-122"/>
                 <a:cs typeface="Cambria" pitchFamily="34" charset="-120"/>
               </a:rPr>
-              <a:t>Pattern: the search is overhead, not work</a:t>
+              <a:t>Latency scaling analysis</a:t>
             </a:r>
             <a:endParaRPr lang="en-US" sz="2800" dirty="0"/>
           </a:p>
@@ -7929,7 +7929,7 @@
                 <a:ea typeface="Calibri" pitchFamily="34" charset="-122"/>
                 <a:cs typeface="Calibri" pitchFamily="34" charset="-120"/>
               </a:rPr>
-              <a:t>Fitted model: 20.0 ms fixed + 0.10 ms per 100 candidates. Cost does not depend on how much work is done.</a:t>
+              <a:t>Fitted model: 20.0 ms fixed + 0.10 ms per 100 candidates. Latency is effectively independent of workload.</a:t>
             </a:r>
             <a:endParaRPr lang="en-US" sz="1100" dirty="0"/>
           </a:p>
@@ -7950,7 +7950,7 @@
                 <a:ea typeface="Calibri" pitchFamily="34" charset="-122"/>
                 <a:cs typeface="Calibri" pitchFamily="34" charset="-120"/>
               </a:rPr>
-              <a:t>So cutting candidates (iCEM) cannot help here: predicted 1.01×, observed 0.92×.</a:t>
+              <a:t>Reducing the candidate count (iCEM) therefore yields no gain: predicted 1.01×, observed 0.92×.</a:t>
             </a:r>
             <a:endParaRPr lang="en-US" sz="1100" dirty="0"/>
           </a:p>
@@ -7971,7 +7971,7 @@
                 <a:ea typeface="Calibri" pitchFamily="34" charset="-122"/>
                 <a:cs typeface="Calibri" pitchFamily="34" charset="-120"/>
               </a:rPr>
-              <a:t>Only an execution with little fixed cost turns fewer candidates into less time.</a:t>
+              <a:t>A gain requires an execution model with low fixed cost per call.</a:t>
             </a:r>
             <a:endParaRPr lang="en-US" sz="1100" dirty="0"/>
           </a:p>
@@ -8113,7 +8113,7 @@
                 <a:ea typeface="Cambria" pitchFamily="34" charset="-122"/>
                 <a:cs typeface="Cambria" pitchFamily="34" charset="-120"/>
               </a:rPr>
-              <a:t>Solution: LeWM-MK, one GPU program per plan</a:t>
+              <a:t>Solution design: LeWM-MK</a:t>
             </a:r>
             <a:endParaRPr lang="en-US" sz="2800" dirty="0"/>
           </a:p>

</xml_diff>

<commit_message>
Show planning latency as box plots instead of a jittered strip plot
Co-Authored-By: Claude Opus 5.5 <noreply@anthropic.com>
</commit_message>
<xml_diff>
--- a/docs/paper/presentation.pptx
+++ b/docs/paper/presentation.pptx
@@ -2272,8 +2272,8 @@
         </p:blipFill>
         <p:spPr>
           <a:xfrm>
-            <a:off x="457200" y="1113174"/>
-            <a:ext cx="5669280" cy="1797011"/>
+            <a:off x="457200" y="1237802"/>
+            <a:ext cx="5669280" cy="1547756"/>
           </a:xfrm>
           <a:prstGeom prst="rect">
             <a:avLst/>
@@ -2642,7 +2642,7 @@
                 <a:ea typeface="Calibri" pitchFamily="34" charset="-122"/>
                 <a:cs typeface="Calibri" pitchFamily="34" charset="-120"/>
               </a:rPr>
-              <a:t>End-to-end planning latency, log scale; points are plans, diamonds medians. Baseline already uses compile, CUDA Graphs and BF16.</a:t>
+              <a:t>End-to-end planning latency, log scale: median, interquartile box, 1.5-IQR whiskers, outlying plans. Baseline uses compile, CUDA Graphs and BF16.</a:t>
             </a:r>
             <a:endParaRPr lang="en-US" sz="1000" dirty="0"/>
           </a:p>

</xml_diff>